<commit_message>
finished draft migration guide
</commit_message>
<xml_diff>
--- a/docs/slack-plus-teams-architecture.pptx
+++ b/docs/slack-plus-teams-architecture.pptx
@@ -5,12 +5,13 @@
     <p:sldMasterId id="2147483648" r:id="rId1"/>
   </p:sldMasterIdLst>
   <p:notesMasterIdLst>
-    <p:notesMasterId r:id="rId5"/>
+    <p:notesMasterId r:id="rId6"/>
   </p:notesMasterIdLst>
   <p:sldIdLst>
     <p:sldId id="256" r:id="rId2"/>
     <p:sldId id="257" r:id="rId3"/>
     <p:sldId id="258" r:id="rId4"/>
+    <p:sldId id="259" r:id="rId5"/>
   </p:sldIdLst>
   <p:sldSz cx="12192000" cy="6858000"/>
   <p:notesSz cx="6858000" cy="12192000"/>
@@ -1655,8 +1656,8 @@
         </p:nvSpPr>
         <p:spPr>
           <a:xfrm>
-            <a:off x="3584448" y="493776"/>
-            <a:ext cx="8046720" cy="219456"/>
+            <a:off x="3584448" y="411479"/>
+            <a:ext cx="8046720" cy="713231"/>
           </a:xfrm>
           <a:prstGeom prst="rect">
             <a:avLst/>
@@ -2564,8 +2565,8 @@
         </p:nvSpPr>
         <p:spPr>
           <a:xfrm>
-            <a:off x="4800000" y="493776"/>
-            <a:ext cx="7000000" cy="219456"/>
+            <a:off x="4800000" y="411480"/>
+            <a:ext cx="7000000" cy="713232"/>
           </a:xfrm>
           <a:prstGeom prst="rect">
             <a:avLst/>
@@ -2595,7 +2596,7 @@
           <a:p>
             <a:pPr algn="l"/>
             <a:r>
-              <a:rPr sz="1350" b="0">
+              <a:rPr sz="1350" b="0" dirty="0">
                 <a:solidFill>
                   <a:srgbClr val="6D6D6D"/>
                 </a:solidFill>
@@ -3644,6 +3645,1089 @@
                 </a:solidFill>
               </a:rPr>
               <a:t>Slack to Teams migration guide • architecture diagram 3 of 7</a:t>
+            </a:r>
+          </a:p>
+        </p:txBody>
+      </p:sp>
+    </p:spTree>
+  </p:cSld>
+  <p:clrMapOvr>
+    <a:masterClrMapping/>
+  </p:clrMapOvr>
+</p:sld>
+</file>
+
+<file path=ppt/slides/slide4.xml><?xml version="1.0" encoding="utf-8"?>
+<p:sld xmlns:a="http://schemas.openxmlformats.org/drawingml/2006/main" xmlns:r="http://schemas.openxmlformats.org/officeDocument/2006/relationships" xmlns:p="http://schemas.openxmlformats.org/presentationml/2006/main">
+  <p:cSld>
+    <p:spTree>
+      <p:nvGrpSpPr>
+        <p:cNvPr id="1" name=""/>
+        <p:cNvGrpSpPr/>
+        <p:nvPr/>
+      </p:nvGrpSpPr>
+      <p:grpSpPr>
+        <a:xfrm>
+          <a:off x="0" y="0"/>
+          <a:ext cx="0" cy="0"/>
+          <a:chOff x="0" y="0"/>
+          <a:chExt cx="0" cy="0"/>
+        </a:xfrm>
+      </p:grpSpPr>
+      <p:sp>
+        <p:nvSpPr>
+          <p:cNvPr id="2" name="Rectangle 1"/>
+          <p:cNvSpPr/>
+          <p:nvPr/>
+        </p:nvSpPr>
+        <p:spPr>
+          <a:xfrm>
+            <a:off x="109728" y="411480"/>
+            <a:ext cx="4500000" cy="713232"/>
+          </a:xfrm>
+          <a:prstGeom prst="rect">
+            <a:avLst/>
+          </a:prstGeom>
+          <a:solidFill>
+            <a:srgbClr val="4B4A78"/>
+          </a:solidFill>
+          <a:ln>
+            <a:noFill/>
+          </a:ln>
+        </p:spPr>
+        <p:style>
+          <a:lnRef idx="1">
+            <a:schemeClr val="accent1"/>
+          </a:lnRef>
+          <a:fillRef idx="3">
+            <a:schemeClr val="accent1"/>
+          </a:fillRef>
+          <a:effectRef idx="2">
+            <a:schemeClr val="accent1"/>
+          </a:effectRef>
+          <a:fontRef idx="minor">
+            <a:schemeClr val="lt1"/>
+          </a:fontRef>
+        </p:style>
+        <p:txBody>
+          <a:bodyPr wrap="square" rtlCol="0" anchor="ctr"/>
+          <a:lstStyle/>
+          <a:p>
+            <a:pPr algn="ctr"/>
+            <a:r>
+              <a:rPr sz="2200" b="1">
+                <a:solidFill>
+                  <a:srgbClr val="FFFFFF"/>
+                </a:solidFill>
+              </a:rPr>
+              <a:t>Adapter Pattern Architecture</a:t>
+            </a:r>
+          </a:p>
+        </p:txBody>
+      </p:sp>
+      <p:sp>
+        <p:nvSpPr>
+          <p:cNvPr id="3" name="Rectangle 2"/>
+          <p:cNvSpPr/>
+          <p:nvPr/>
+        </p:nvSpPr>
+        <p:spPr>
+          <a:xfrm>
+            <a:off x="4800000" y="411480"/>
+            <a:ext cx="7200000" cy="713232"/>
+          </a:xfrm>
+          <a:prstGeom prst="rect">
+            <a:avLst/>
+          </a:prstGeom>
+          <a:noFill/>
+          <a:ln>
+            <a:noFill/>
+          </a:ln>
+        </p:spPr>
+        <p:style>
+          <a:lnRef idx="1">
+            <a:schemeClr val="accent1"/>
+          </a:lnRef>
+          <a:fillRef idx="3">
+            <a:schemeClr val="accent1"/>
+          </a:fillRef>
+          <a:effectRef idx="2">
+            <a:schemeClr val="accent1"/>
+          </a:effectRef>
+          <a:fontRef idx="minor">
+            <a:schemeClr val="lt1"/>
+          </a:fontRef>
+        </p:style>
+        <p:txBody>
+          <a:bodyPr wrap="square" rtlCol="0" anchor="ctr"/>
+          <a:lstStyle/>
+          <a:p>
+            <a:pPr algn="l"/>
+            <a:r>
+              <a:rPr sz="1350" b="0" dirty="0">
+                <a:solidFill>
+                  <a:srgbClr val="6D6D6D"/>
+                </a:solidFill>
+              </a:rPr>
+              <a:t>Inbound calls from each platform converge on a shared service layer</a:t>
+            </a:r>
+          </a:p>
+        </p:txBody>
+      </p:sp>
+      <p:sp>
+        <p:nvSpPr>
+          <p:cNvPr id="4" name="Rounded Rectangle 3"/>
+          <p:cNvSpPr/>
+          <p:nvPr/>
+        </p:nvSpPr>
+        <p:spPr>
+          <a:xfrm>
+            <a:off x="4796000" y="2700000"/>
+            <a:ext cx="2600000" cy="2000000"/>
+          </a:xfrm>
+          <a:prstGeom prst="roundRect">
+            <a:avLst>
+              <a:gd name="adj" fmla="val 4000"/>
+            </a:avLst>
+          </a:prstGeom>
+          <a:solidFill>
+            <a:srgbClr val="E8F5E9"/>
+          </a:solidFill>
+          <a:ln w="19050">
+            <a:solidFill>
+              <a:srgbClr val="2E7D32"/>
+            </a:solidFill>
+          </a:ln>
+        </p:spPr>
+        <p:style>
+          <a:lnRef idx="1">
+            <a:schemeClr val="accent1"/>
+          </a:lnRef>
+          <a:fillRef idx="3">
+            <a:schemeClr val="accent1"/>
+          </a:fillRef>
+          <a:effectRef idx="2">
+            <a:schemeClr val="accent1"/>
+          </a:effectRef>
+          <a:fontRef idx="minor">
+            <a:schemeClr val="lt1"/>
+          </a:fontRef>
+        </p:style>
+        <p:txBody>
+          <a:bodyPr wrap="square" tIns="36000" bIns="36000" rtlCol="0" anchor="ctr"/>
+          <a:lstStyle/>
+          <a:p>
+            <a:pPr algn="ctr"/>
+            <a:r>
+              <a:rPr sz="1300" b="1">
+                <a:solidFill>
+                  <a:srgbClr val="2E7D32"/>
+                </a:solidFill>
+              </a:rPr>
+              <a:t>Shared Service Layer</a:t>
+            </a:r>
+          </a:p>
+          <a:p>
+            <a:pPr algn="ctr"/>
+            <a:r>
+              <a:rPr sz="950" b="0">
+                <a:solidFill>
+                  <a:srgbClr val="2E7D32"/>
+                </a:solidFill>
+              </a:rPr>
+              <a:t>Business logic</a:t>
+            </a:r>
+          </a:p>
+          <a:p>
+            <a:pPr algn="ctr"/>
+            <a:r>
+              <a:rPr sz="950" b="0">
+                <a:solidFill>
+                  <a:srgbClr val="2E7D32"/>
+                </a:solidFill>
+              </a:rPr>
+              <a:t>AI / LLM calls</a:t>
+            </a:r>
+          </a:p>
+          <a:p>
+            <a:pPr algn="ctr"/>
+            <a:r>
+              <a:rPr sz="950" b="0">
+                <a:solidFill>
+                  <a:srgbClr val="2E7D32"/>
+                </a:solidFill>
+              </a:rPr>
+              <a:t>Data access</a:t>
+            </a:r>
+          </a:p>
+          <a:p>
+            <a:pPr algn="ctr"/>
+            <a:r>
+              <a:rPr sz="950" b="0">
+                <a:solidFill>
+                  <a:srgbClr val="2E7D32"/>
+                </a:solidFill>
+              </a:rPr>
+              <a:t>Common types</a:t>
+            </a:r>
+          </a:p>
+        </p:txBody>
+      </p:sp>
+      <p:sp>
+        <p:nvSpPr>
+          <p:cNvPr id="5" name="Rounded Rectangle 4"/>
+          <p:cNvSpPr/>
+          <p:nvPr/>
+        </p:nvSpPr>
+        <p:spPr>
+          <a:xfrm>
+            <a:off x="2596000" y="3000000"/>
+            <a:ext cx="1800000" cy="1400000"/>
+          </a:xfrm>
+          <a:prstGeom prst="roundRect">
+            <a:avLst>
+              <a:gd name="adj" fmla="val 4000"/>
+            </a:avLst>
+          </a:prstGeom>
+          <a:solidFill>
+            <a:srgbClr val="E8E8F0"/>
+          </a:solidFill>
+          <a:ln w="19050">
+            <a:solidFill>
+              <a:srgbClr val="4B4A78"/>
+            </a:solidFill>
+          </a:ln>
+        </p:spPr>
+        <p:style>
+          <a:lnRef idx="1">
+            <a:schemeClr val="accent1"/>
+          </a:lnRef>
+          <a:fillRef idx="3">
+            <a:schemeClr val="accent1"/>
+          </a:fillRef>
+          <a:effectRef idx="2">
+            <a:schemeClr val="accent1"/>
+          </a:effectRef>
+          <a:fontRef idx="minor">
+            <a:schemeClr val="lt1"/>
+          </a:fontRef>
+        </p:style>
+        <p:txBody>
+          <a:bodyPr wrap="square" tIns="36000" bIns="36000" rtlCol="0" anchor="ctr"/>
+          <a:lstStyle/>
+          <a:p>
+            <a:pPr algn="ctr"/>
+            <a:r>
+              <a:rPr sz="1300" b="1">
+                <a:solidFill>
+                  <a:srgbClr val="4B4A78"/>
+                </a:solidFill>
+              </a:rPr>
+              <a:t>Slack Adapter</a:t>
+            </a:r>
+          </a:p>
+          <a:p>
+            <a:pPr algn="ctr"/>
+            <a:r>
+              <a:rPr sz="950" b="0">
+                <a:solidFill>
+                  <a:srgbClr val="4B4A78"/>
+                </a:solidFill>
+              </a:rPr>
+              <a:t>@slack/bolt</a:t>
+            </a:r>
+          </a:p>
+          <a:p>
+            <a:pPr algn="ctr"/>
+            <a:r>
+              <a:rPr sz="950" b="0">
+                <a:solidFill>
+                  <a:srgbClr val="4B4A78"/>
+                </a:solidFill>
+              </a:rPr>
+              <a:t>Event handlers</a:t>
+            </a:r>
+          </a:p>
+          <a:p>
+            <a:pPr algn="ctr"/>
+            <a:r>
+              <a:rPr sz="950" b="0">
+                <a:solidFill>
+                  <a:srgbClr val="4B4A78"/>
+                </a:solidFill>
+              </a:rPr>
+              <a:t>Block Kit</a:t>
+            </a:r>
+          </a:p>
+        </p:txBody>
+      </p:sp>
+      <p:sp>
+        <p:nvSpPr>
+          <p:cNvPr id="6" name="Rounded Rectangle 5"/>
+          <p:cNvSpPr/>
+          <p:nvPr/>
+        </p:nvSpPr>
+        <p:spPr>
+          <a:xfrm>
+            <a:off x="7796000" y="3000000"/>
+            <a:ext cx="1800000" cy="1400000"/>
+          </a:xfrm>
+          <a:prstGeom prst="roundRect">
+            <a:avLst>
+              <a:gd name="adj" fmla="val 4000"/>
+            </a:avLst>
+          </a:prstGeom>
+          <a:solidFill>
+            <a:srgbClr val="E8E8F0"/>
+          </a:solidFill>
+          <a:ln w="19050">
+            <a:solidFill>
+              <a:srgbClr val="4B4A78"/>
+            </a:solidFill>
+          </a:ln>
+        </p:spPr>
+        <p:style>
+          <a:lnRef idx="1">
+            <a:schemeClr val="accent1"/>
+          </a:lnRef>
+          <a:fillRef idx="3">
+            <a:schemeClr val="accent1"/>
+          </a:fillRef>
+          <a:effectRef idx="2">
+            <a:schemeClr val="accent1"/>
+          </a:effectRef>
+          <a:fontRef idx="minor">
+            <a:schemeClr val="lt1"/>
+          </a:fontRef>
+        </p:style>
+        <p:txBody>
+          <a:bodyPr wrap="square" tIns="36000" bIns="36000" rtlCol="0" anchor="ctr"/>
+          <a:lstStyle/>
+          <a:p>
+            <a:pPr algn="ctr"/>
+            <a:r>
+              <a:rPr sz="1300" b="1">
+                <a:solidFill>
+                  <a:srgbClr val="4B4A78"/>
+                </a:solidFill>
+              </a:rPr>
+              <a:t>Teams Adapter</a:t>
+            </a:r>
+          </a:p>
+          <a:p>
+            <a:pPr algn="ctr"/>
+            <a:r>
+              <a:rPr sz="950" b="0">
+                <a:solidFill>
+                  <a:srgbClr val="4B4A78"/>
+                </a:solidFill>
+              </a:rPr>
+              <a:t>Agents SDK</a:t>
+            </a:r>
+          </a:p>
+          <a:p>
+            <a:pPr algn="ctr"/>
+            <a:r>
+              <a:rPr sz="950" b="0">
+                <a:solidFill>
+                  <a:srgbClr val="4B4A78"/>
+                </a:solidFill>
+              </a:rPr>
+              <a:t>Activity handlers</a:t>
+            </a:r>
+          </a:p>
+          <a:p>
+            <a:pPr algn="ctr"/>
+            <a:r>
+              <a:rPr sz="950" b="0">
+                <a:solidFill>
+                  <a:srgbClr val="4B4A78"/>
+                </a:solidFill>
+              </a:rPr>
+              <a:t>Adaptive Cards</a:t>
+            </a:r>
+          </a:p>
+        </p:txBody>
+      </p:sp>
+      <p:sp>
+        <p:nvSpPr>
+          <p:cNvPr id="7" name="Rounded Rectangle 6"/>
+          <p:cNvSpPr/>
+          <p:nvPr/>
+        </p:nvSpPr>
+        <p:spPr>
+          <a:xfrm>
+            <a:off x="746000" y="3200000"/>
+            <a:ext cx="1500000" cy="1000000"/>
+          </a:xfrm>
+          <a:prstGeom prst="roundRect">
+            <a:avLst>
+              <a:gd name="adj" fmla="val 4000"/>
+            </a:avLst>
+          </a:prstGeom>
+          <a:solidFill>
+            <a:srgbClr val="4B4A78"/>
+          </a:solidFill>
+          <a:ln>
+            <a:noFill/>
+          </a:ln>
+        </p:spPr>
+        <p:style>
+          <a:lnRef idx="1">
+            <a:schemeClr val="accent1"/>
+          </a:lnRef>
+          <a:fillRef idx="3">
+            <a:schemeClr val="accent1"/>
+          </a:fillRef>
+          <a:effectRef idx="2">
+            <a:schemeClr val="accent1"/>
+          </a:effectRef>
+          <a:fontRef idx="minor">
+            <a:schemeClr val="lt1"/>
+          </a:fontRef>
+        </p:style>
+        <p:txBody>
+          <a:bodyPr wrap="square" tIns="36000" bIns="36000" rtlCol="0" anchor="ctr"/>
+          <a:lstStyle/>
+          <a:p>
+            <a:pPr algn="ctr"/>
+            <a:r>
+              <a:rPr sz="1300" b="1">
+                <a:solidFill>
+                  <a:srgbClr val="FFFFFF"/>
+                </a:solidFill>
+              </a:rPr>
+              <a:t>Slack</a:t>
+            </a:r>
+          </a:p>
+          <a:p>
+            <a:pPr algn="ctr"/>
+            <a:r>
+              <a:rPr sz="950" b="0">
+                <a:solidFill>
+                  <a:srgbClr val="FFFFFF"/>
+                </a:solidFill>
+              </a:rPr>
+              <a:t>WebSocket</a:t>
+            </a:r>
+          </a:p>
+          <a:p>
+            <a:pPr algn="ctr"/>
+            <a:r>
+              <a:rPr sz="950" b="0">
+                <a:solidFill>
+                  <a:srgbClr val="FFFFFF"/>
+                </a:solidFill>
+              </a:rPr>
+              <a:t>Socket Mode</a:t>
+            </a:r>
+          </a:p>
+        </p:txBody>
+      </p:sp>
+      <p:sp>
+        <p:nvSpPr>
+          <p:cNvPr id="8" name="Rounded Rectangle 7"/>
+          <p:cNvSpPr/>
+          <p:nvPr/>
+        </p:nvSpPr>
+        <p:spPr>
+          <a:xfrm>
+            <a:off x="9946000" y="3200000"/>
+            <a:ext cx="1500000" cy="1000000"/>
+          </a:xfrm>
+          <a:prstGeom prst="roundRect">
+            <a:avLst>
+              <a:gd name="adj" fmla="val 4000"/>
+            </a:avLst>
+          </a:prstGeom>
+          <a:solidFill>
+            <a:srgbClr val="4B4A78"/>
+          </a:solidFill>
+          <a:ln>
+            <a:noFill/>
+          </a:ln>
+        </p:spPr>
+        <p:style>
+          <a:lnRef idx="1">
+            <a:schemeClr val="accent1"/>
+          </a:lnRef>
+          <a:fillRef idx="3">
+            <a:schemeClr val="accent1"/>
+          </a:fillRef>
+          <a:effectRef idx="2">
+            <a:schemeClr val="accent1"/>
+          </a:effectRef>
+          <a:fontRef idx="minor">
+            <a:schemeClr val="lt1"/>
+          </a:fontRef>
+        </p:style>
+        <p:txBody>
+          <a:bodyPr wrap="square" tIns="36000" bIns="36000" rtlCol="0" anchor="ctr"/>
+          <a:lstStyle/>
+          <a:p>
+            <a:pPr algn="ctr"/>
+            <a:r>
+              <a:rPr sz="1300" b="1">
+                <a:solidFill>
+                  <a:srgbClr val="FFFFFF"/>
+                </a:solidFill>
+              </a:rPr>
+              <a:t>Microsoft Teams</a:t>
+            </a:r>
+          </a:p>
+          <a:p>
+            <a:pPr algn="ctr"/>
+            <a:r>
+              <a:rPr sz="950" b="0">
+                <a:solidFill>
+                  <a:srgbClr val="FFFFFF"/>
+                </a:solidFill>
+              </a:rPr>
+              <a:t>HTTPS</a:t>
+            </a:r>
+          </a:p>
+          <a:p>
+            <a:pPr algn="ctr"/>
+            <a:r>
+              <a:rPr sz="950" b="0">
+                <a:solidFill>
+                  <a:srgbClr val="FFFFFF"/>
+                </a:solidFill>
+              </a:rPr>
+              <a:t>Bot Framework</a:t>
+            </a:r>
+          </a:p>
+        </p:txBody>
+      </p:sp>
+      <p:cxnSp>
+        <p:nvCxnSpPr>
+          <p:cNvPr id="9" name="Connector 8"/>
+          <p:cNvCxnSpPr/>
+          <p:nvPr/>
+        </p:nvCxnSpPr>
+        <p:spPr>
+          <a:xfrm>
+            <a:off x="2246000" y="3550000"/>
+            <a:ext cx="350000" cy="0"/>
+          </a:xfrm>
+          <a:prstGeom prst="line">
+            <a:avLst/>
+          </a:prstGeom>
+          <a:ln w="25400">
+            <a:solidFill>
+              <a:srgbClr val="4B4A78"/>
+            </a:solidFill>
+            <a:tailEnd type="triangle" w="med" len="med"/>
+          </a:ln>
+        </p:spPr>
+        <p:style>
+          <a:lnRef idx="2">
+            <a:schemeClr val="accent1"/>
+          </a:lnRef>
+          <a:fillRef idx="0">
+            <a:schemeClr val="accent1"/>
+          </a:fillRef>
+          <a:effectRef idx="1">
+            <a:schemeClr val="accent1"/>
+          </a:effectRef>
+          <a:fontRef idx="minor">
+            <a:schemeClr val="tx1"/>
+          </a:fontRef>
+        </p:style>
+      </p:cxnSp>
+      <p:cxnSp>
+        <p:nvCxnSpPr>
+          <p:cNvPr id="10" name="Connector 9"/>
+          <p:cNvCxnSpPr/>
+          <p:nvPr/>
+        </p:nvCxnSpPr>
+        <p:spPr>
+          <a:xfrm>
+            <a:off x="4396000" y="3550000"/>
+            <a:ext cx="400000" cy="0"/>
+          </a:xfrm>
+          <a:prstGeom prst="line">
+            <a:avLst/>
+          </a:prstGeom>
+          <a:ln w="25400">
+            <a:solidFill>
+              <a:srgbClr val="4B4A78"/>
+            </a:solidFill>
+            <a:tailEnd type="triangle" w="med" len="med"/>
+          </a:ln>
+        </p:spPr>
+        <p:style>
+          <a:lnRef idx="2">
+            <a:schemeClr val="accent1"/>
+          </a:lnRef>
+          <a:fillRef idx="0">
+            <a:schemeClr val="accent1"/>
+          </a:fillRef>
+          <a:effectRef idx="1">
+            <a:schemeClr val="accent1"/>
+          </a:effectRef>
+          <a:fontRef idx="minor">
+            <a:schemeClr val="tx1"/>
+          </a:fontRef>
+        </p:style>
+      </p:cxnSp>
+      <p:cxnSp>
+        <p:nvCxnSpPr>
+          <p:cNvPr id="11" name="Connector 10"/>
+          <p:cNvCxnSpPr/>
+          <p:nvPr/>
+        </p:nvCxnSpPr>
+        <p:spPr>
+          <a:xfrm flipH="1">
+            <a:off x="4396000" y="3850000"/>
+            <a:ext cx="400000" cy="0"/>
+          </a:xfrm>
+          <a:prstGeom prst="line">
+            <a:avLst/>
+          </a:prstGeom>
+          <a:ln w="25400">
+            <a:solidFill>
+              <a:srgbClr val="4B4A78"/>
+            </a:solidFill>
+            <a:tailEnd type="triangle" w="med" len="med"/>
+          </a:ln>
+        </p:spPr>
+        <p:style>
+          <a:lnRef idx="2">
+            <a:schemeClr val="accent1"/>
+          </a:lnRef>
+          <a:fillRef idx="0">
+            <a:schemeClr val="accent1"/>
+          </a:fillRef>
+          <a:effectRef idx="1">
+            <a:schemeClr val="accent1"/>
+          </a:effectRef>
+          <a:fontRef idx="minor">
+            <a:schemeClr val="tx1"/>
+          </a:fontRef>
+        </p:style>
+      </p:cxnSp>
+      <p:cxnSp>
+        <p:nvCxnSpPr>
+          <p:cNvPr id="12" name="Connector 11"/>
+          <p:cNvCxnSpPr/>
+          <p:nvPr/>
+        </p:nvCxnSpPr>
+        <p:spPr>
+          <a:xfrm flipH="1">
+            <a:off x="2246000" y="3850000"/>
+            <a:ext cx="350000" cy="0"/>
+          </a:xfrm>
+          <a:prstGeom prst="line">
+            <a:avLst/>
+          </a:prstGeom>
+          <a:ln w="25400">
+            <a:solidFill>
+              <a:srgbClr val="4B4A78"/>
+            </a:solidFill>
+            <a:tailEnd type="triangle" w="med" len="med"/>
+          </a:ln>
+        </p:spPr>
+        <p:style>
+          <a:lnRef idx="2">
+            <a:schemeClr val="accent1"/>
+          </a:lnRef>
+          <a:fillRef idx="0">
+            <a:schemeClr val="accent1"/>
+          </a:fillRef>
+          <a:effectRef idx="1">
+            <a:schemeClr val="accent1"/>
+          </a:effectRef>
+          <a:fontRef idx="minor">
+            <a:schemeClr val="tx1"/>
+          </a:fontRef>
+        </p:style>
+      </p:cxnSp>
+      <p:cxnSp>
+        <p:nvCxnSpPr>
+          <p:cNvPr id="13" name="Connector 12"/>
+          <p:cNvCxnSpPr/>
+          <p:nvPr/>
+        </p:nvCxnSpPr>
+        <p:spPr>
+          <a:xfrm flipH="1">
+            <a:off x="9596000" y="3550000"/>
+            <a:ext cx="350000" cy="0"/>
+          </a:xfrm>
+          <a:prstGeom prst="line">
+            <a:avLst/>
+          </a:prstGeom>
+          <a:ln w="25400">
+            <a:solidFill>
+              <a:srgbClr val="4B4A78"/>
+            </a:solidFill>
+            <a:tailEnd type="triangle" w="med" len="med"/>
+          </a:ln>
+        </p:spPr>
+        <p:style>
+          <a:lnRef idx="2">
+            <a:schemeClr val="accent1"/>
+          </a:lnRef>
+          <a:fillRef idx="0">
+            <a:schemeClr val="accent1"/>
+          </a:fillRef>
+          <a:effectRef idx="1">
+            <a:schemeClr val="accent1"/>
+          </a:effectRef>
+          <a:fontRef idx="minor">
+            <a:schemeClr val="tx1"/>
+          </a:fontRef>
+        </p:style>
+      </p:cxnSp>
+      <p:cxnSp>
+        <p:nvCxnSpPr>
+          <p:cNvPr id="14" name="Connector 13"/>
+          <p:cNvCxnSpPr/>
+          <p:nvPr/>
+        </p:nvCxnSpPr>
+        <p:spPr>
+          <a:xfrm flipH="1">
+            <a:off x="7396000" y="3550000"/>
+            <a:ext cx="400000" cy="0"/>
+          </a:xfrm>
+          <a:prstGeom prst="line">
+            <a:avLst/>
+          </a:prstGeom>
+          <a:ln w="25400">
+            <a:solidFill>
+              <a:srgbClr val="4B4A78"/>
+            </a:solidFill>
+            <a:tailEnd type="triangle" w="med" len="med"/>
+          </a:ln>
+        </p:spPr>
+        <p:style>
+          <a:lnRef idx="2">
+            <a:schemeClr val="accent1"/>
+          </a:lnRef>
+          <a:fillRef idx="0">
+            <a:schemeClr val="accent1"/>
+          </a:fillRef>
+          <a:effectRef idx="1">
+            <a:schemeClr val="accent1"/>
+          </a:effectRef>
+          <a:fontRef idx="minor">
+            <a:schemeClr val="tx1"/>
+          </a:fontRef>
+        </p:style>
+      </p:cxnSp>
+      <p:cxnSp>
+        <p:nvCxnSpPr>
+          <p:cNvPr id="15" name="Connector 14"/>
+          <p:cNvCxnSpPr/>
+          <p:nvPr/>
+        </p:nvCxnSpPr>
+        <p:spPr>
+          <a:xfrm>
+            <a:off x="7396000" y="3850000"/>
+            <a:ext cx="400000" cy="0"/>
+          </a:xfrm>
+          <a:prstGeom prst="line">
+            <a:avLst/>
+          </a:prstGeom>
+          <a:ln w="25400">
+            <a:solidFill>
+              <a:srgbClr val="4B4A78"/>
+            </a:solidFill>
+            <a:tailEnd type="triangle" w="med" len="med"/>
+          </a:ln>
+        </p:spPr>
+        <p:style>
+          <a:lnRef idx="2">
+            <a:schemeClr val="accent1"/>
+          </a:lnRef>
+          <a:fillRef idx="0">
+            <a:schemeClr val="accent1"/>
+          </a:fillRef>
+          <a:effectRef idx="1">
+            <a:schemeClr val="accent1"/>
+          </a:effectRef>
+          <a:fontRef idx="minor">
+            <a:schemeClr val="tx1"/>
+          </a:fontRef>
+        </p:style>
+      </p:cxnSp>
+      <p:cxnSp>
+        <p:nvCxnSpPr>
+          <p:cNvPr id="16" name="Connector 15"/>
+          <p:cNvCxnSpPr/>
+          <p:nvPr/>
+        </p:nvCxnSpPr>
+        <p:spPr>
+          <a:xfrm>
+            <a:off x="9596000" y="3850000"/>
+            <a:ext cx="350000" cy="0"/>
+          </a:xfrm>
+          <a:prstGeom prst="line">
+            <a:avLst/>
+          </a:prstGeom>
+          <a:ln w="25400">
+            <a:solidFill>
+              <a:srgbClr val="4B4A78"/>
+            </a:solidFill>
+            <a:tailEnd type="triangle" w="med" len="med"/>
+          </a:ln>
+        </p:spPr>
+        <p:style>
+          <a:lnRef idx="2">
+            <a:schemeClr val="accent1"/>
+          </a:lnRef>
+          <a:fillRef idx="0">
+            <a:schemeClr val="accent1"/>
+          </a:fillRef>
+          <a:effectRef idx="1">
+            <a:schemeClr val="accent1"/>
+          </a:effectRef>
+          <a:fontRef idx="minor">
+            <a:schemeClr val="tx1"/>
+          </a:fontRef>
+        </p:style>
+      </p:cxnSp>
+      <p:sp>
+        <p:nvSpPr>
+          <p:cNvPr id="17" name="Rectangle 16"/>
+          <p:cNvSpPr/>
+          <p:nvPr/>
+        </p:nvSpPr>
+        <p:spPr>
+          <a:xfrm>
+            <a:off x="1721000" y="2420000"/>
+            <a:ext cx="1400000" cy="220000"/>
+          </a:xfrm>
+          <a:prstGeom prst="rect">
+            <a:avLst/>
+          </a:prstGeom>
+          <a:noFill/>
+          <a:ln>
+            <a:noFill/>
+          </a:ln>
+        </p:spPr>
+        <p:style>
+          <a:lnRef idx="1">
+            <a:schemeClr val="accent1"/>
+          </a:lnRef>
+          <a:fillRef idx="3">
+            <a:schemeClr val="accent1"/>
+          </a:fillRef>
+          <a:effectRef idx="2">
+            <a:schemeClr val="accent1"/>
+          </a:effectRef>
+          <a:fontRef idx="minor">
+            <a:schemeClr val="lt1"/>
+          </a:fontRef>
+        </p:style>
+        <p:txBody>
+          <a:bodyPr wrap="square" rtlCol="0" anchor="ctr"/>
+          <a:lstStyle/>
+          <a:p>
+            <a:pPr algn="ctr"/>
+            <a:r>
+              <a:rPr sz="850" i="1">
+                <a:solidFill>
+                  <a:srgbClr val="7A7A7A"/>
+                </a:solidFill>
+              </a:rPr>
+              <a:t>Events / Messages</a:t>
+            </a:r>
+          </a:p>
+        </p:txBody>
+      </p:sp>
+      <p:sp>
+        <p:nvSpPr>
+          <p:cNvPr id="18" name="Rectangle 17"/>
+          <p:cNvSpPr/>
+          <p:nvPr/>
+        </p:nvSpPr>
+        <p:spPr>
+          <a:xfrm>
+            <a:off x="3896000" y="2420000"/>
+            <a:ext cx="1400000" cy="220000"/>
+          </a:xfrm>
+          <a:prstGeom prst="rect">
+            <a:avLst/>
+          </a:prstGeom>
+          <a:noFill/>
+          <a:ln>
+            <a:noFill/>
+          </a:ln>
+        </p:spPr>
+        <p:style>
+          <a:lnRef idx="1">
+            <a:schemeClr val="accent1"/>
+          </a:lnRef>
+          <a:fillRef idx="3">
+            <a:schemeClr val="accent1"/>
+          </a:fillRef>
+          <a:effectRef idx="2">
+            <a:schemeClr val="accent1"/>
+          </a:effectRef>
+          <a:fontRef idx="minor">
+            <a:schemeClr val="lt1"/>
+          </a:fontRef>
+        </p:style>
+        <p:txBody>
+          <a:bodyPr wrap="square" rtlCol="0" anchor="ctr"/>
+          <a:lstStyle/>
+          <a:p>
+            <a:pPr algn="ctr"/>
+            <a:r>
+              <a:rPr sz="850" i="1">
+                <a:solidFill>
+                  <a:srgbClr val="7A7A7A"/>
+                </a:solidFill>
+              </a:rPr>
+              <a:t>Normalized Calls</a:t>
+            </a:r>
+          </a:p>
+        </p:txBody>
+      </p:sp>
+      <p:sp>
+        <p:nvSpPr>
+          <p:cNvPr id="19" name="Rectangle 18"/>
+          <p:cNvSpPr/>
+          <p:nvPr/>
+        </p:nvSpPr>
+        <p:spPr>
+          <a:xfrm>
+            <a:off x="9071000" y="2420000"/>
+            <a:ext cx="1400000" cy="220000"/>
+          </a:xfrm>
+          <a:prstGeom prst="rect">
+            <a:avLst/>
+          </a:prstGeom>
+          <a:noFill/>
+          <a:ln>
+            <a:noFill/>
+          </a:ln>
+        </p:spPr>
+        <p:style>
+          <a:lnRef idx="1">
+            <a:schemeClr val="accent1"/>
+          </a:lnRef>
+          <a:fillRef idx="3">
+            <a:schemeClr val="accent1"/>
+          </a:fillRef>
+          <a:effectRef idx="2">
+            <a:schemeClr val="accent1"/>
+          </a:effectRef>
+          <a:fontRef idx="minor">
+            <a:schemeClr val="lt1"/>
+          </a:fontRef>
+        </p:style>
+        <p:txBody>
+          <a:bodyPr wrap="square" rtlCol="0" anchor="ctr"/>
+          <a:lstStyle/>
+          <a:p>
+            <a:pPr algn="ctr"/>
+            <a:r>
+              <a:rPr sz="850" i="1">
+                <a:solidFill>
+                  <a:srgbClr val="7A7A7A"/>
+                </a:solidFill>
+              </a:rPr>
+              <a:t>Activities / Messages</a:t>
+            </a:r>
+          </a:p>
+        </p:txBody>
+      </p:sp>
+      <p:sp>
+        <p:nvSpPr>
+          <p:cNvPr id="20" name="Rectangle 19"/>
+          <p:cNvSpPr/>
+          <p:nvPr/>
+        </p:nvSpPr>
+        <p:spPr>
+          <a:xfrm>
+            <a:off x="6896000" y="2420000"/>
+            <a:ext cx="1400000" cy="220000"/>
+          </a:xfrm>
+          <a:prstGeom prst="rect">
+            <a:avLst/>
+          </a:prstGeom>
+          <a:noFill/>
+          <a:ln>
+            <a:noFill/>
+          </a:ln>
+        </p:spPr>
+        <p:style>
+          <a:lnRef idx="1">
+            <a:schemeClr val="accent1"/>
+          </a:lnRef>
+          <a:fillRef idx="3">
+            <a:schemeClr val="accent1"/>
+          </a:fillRef>
+          <a:effectRef idx="2">
+            <a:schemeClr val="accent1"/>
+          </a:effectRef>
+          <a:fontRef idx="minor">
+            <a:schemeClr val="lt1"/>
+          </a:fontRef>
+        </p:style>
+        <p:txBody>
+          <a:bodyPr wrap="square" rtlCol="0" anchor="ctr"/>
+          <a:lstStyle/>
+          <a:p>
+            <a:pPr algn="ctr"/>
+            <a:r>
+              <a:rPr sz="850" i="1">
+                <a:solidFill>
+                  <a:srgbClr val="7A7A7A"/>
+                </a:solidFill>
+              </a:rPr>
+              <a:t>Normalized Calls</a:t>
+            </a:r>
+          </a:p>
+        </p:txBody>
+      </p:sp>
+      <p:sp>
+        <p:nvSpPr>
+          <p:cNvPr id="21" name="Rectangle 20"/>
+          <p:cNvSpPr/>
+          <p:nvPr/>
+        </p:nvSpPr>
+        <p:spPr>
+          <a:xfrm>
+            <a:off x="219456" y="6455664"/>
+            <a:ext cx="6035040" cy="128016"/>
+          </a:xfrm>
+          <a:prstGeom prst="rect">
+            <a:avLst/>
+          </a:prstGeom>
+          <a:noFill/>
+          <a:ln>
+            <a:noFill/>
+          </a:ln>
+        </p:spPr>
+        <p:style>
+          <a:lnRef idx="1">
+            <a:schemeClr val="accent1"/>
+          </a:lnRef>
+          <a:fillRef idx="3">
+            <a:schemeClr val="accent1"/>
+          </a:fillRef>
+          <a:effectRef idx="2">
+            <a:schemeClr val="accent1"/>
+          </a:effectRef>
+          <a:fontRef idx="minor">
+            <a:schemeClr val="lt1"/>
+          </a:fontRef>
+        </p:style>
+        <p:txBody>
+          <a:bodyPr wrap="square" rtlCol="0" anchor="ctr"/>
+          <a:lstStyle/>
+          <a:p>
+            <a:pPr algn="l"/>
+            <a:r>
+              <a:rPr sz="950" b="0">
+                <a:solidFill>
+                  <a:srgbClr val="7A7A7A"/>
+                </a:solidFill>
+              </a:rPr>
+              <a:t>Slack to Teams migration guide • architecture diagram 4 of 7</a:t>
             </a:r>
           </a:p>
         </p:txBody>

</xml_diff>